<commit_message>
Update workshop for ESP32-S3-DevKitC-1 hardware
Use the RGB LED on GPIO 38 with GPIO 48 as the original-board fallback,
document the UART and native USB connectors, update S3 pin and peripheral
information, discard the first touch calibration sample, and refresh the deck.

Tested on an ESP32-S3-DevKitC-1: Tasks 1-4 work on hardware; Task 5 boots,
starts its access point and web server, and initializes ESP-NOW successfully.
</commit_message>
<xml_diff>
--- a/slides/ESP32_Workshop.pptx
+++ b/slides/ESP32_Workshop.pptx
@@ -897,7 +897,7 @@
           <a:p/>
           <a:p>
             <a:r>
-              <a:t>One design decision in the repo: pin numbers and your board's name live in a small file called config.h next to each sketch. If your board's LED is on 38 instead of 48, you change one line there and every task works. The small setLed function at the bottom is the only place that knows what kind of LED the board has.</a:t>
+              <a:t>One design decision in the repo: pin numbers and your board's name live in a small file called config.h next to each sketch. If your board's LED is on 48 instead of 38, you change one line there and every task works. The small setLed function at the bottom is the only place that knows what kind of LED the board has.</a:t>
             </a:r>
           </a:p>
           <a:p/>
@@ -985,7 +985,7 @@
           <a:p/>
           <a:p>
             <a:r>
-              <a:t>If upload succeeded but nothing lights, you have the v1.1 revision of the board: open config.h, change LED_PIN from 48 to 38, upload again. If you are done early, the SOS and heartbeat variations are good practice, and since it is an RGB LED you can give it a colour: rgbLedWrite with red, green, blue values. Fifteen minutes.</a:t>
+              <a:t>If upload succeeded but nothing lights, you have the original revision of the board: open config.h, change LED_PIN from 38 to 48, upload again. If you are done early, the SOS and heartbeat variations are good practice, and since it is an RGB LED you can give it a colour: rgbLedWrite with red, green, blue values. Fifteen minutes.</a:t>
             </a:r>
           </a:p>
         </p:txBody>
@@ -3073,7 +3073,7 @@
           <a:p/>
           <a:p>
             <a:r>
-              <a:t>The LED is not a plain LED. It is an addressable RGB LED, the same kind as in LED strips, driven by a single data pin. On the original board that pin is 48, on the v1.1 revision it is 38, and you cannot tell which you have by looking. Our config.h says 48; if nothing lights up in Task 1, change it to 38. The red LED near the connectors is just power.</a:t>
+              <a:t>The LED is not a plain LED. It is an addressable RGB LED, the same kind as in LED strips, driven by a single data pin. On the v1.1 revision, which is what you have, that pin is 38; on the original it is 48, and you cannot tell by looking. Our config.h says 38; if nothing lights up in Task 1, change it to 48. The red LED near the connectors is just power.</a:t>
             </a:r>
           </a:p>
           <a:p/>
@@ -11236,7 +11236,7 @@
                 </a:solidFill>
                 <a:latin typeface="Courier New"/>
               </a:rPr>
-              <a:t>LED_PIN 48</a:t>
+              <a:t>LED_PIN 38</a:t>
             </a:r>
             <a:r>
               <a:rPr sz="1700" b="0" i="0">
@@ -11254,7 +11254,7 @@
                 </a:solidFill>
                 <a:latin typeface="Courier New"/>
               </a:rPr>
-              <a:t>38</a:t>
+              <a:t>48</a:t>
             </a:r>
             <a:r>
               <a:rPr sz="1700" b="0" i="0">
@@ -38375,7 +38375,7 @@
                 </a:solidFill>
                 <a:latin typeface="Arial"/>
               </a:rPr>
-              <a:t>RGB LED  GPIO 48 or 38</a:t>
+              <a:t>RGB LED  GPIO 38 or 48</a:t>
             </a:r>
           </a:p>
         </p:txBody>
@@ -38705,7 +38705,7 @@
         <p:spPr>
           <a:xfrm>
             <a:off x="6495129" y="1417320"/>
-            <a:ext cx="5010765" cy="4251198"/>
+            <a:ext cx="5010765" cy="4475988"/>
           </a:xfrm>
           <a:prstGeom prst="rect">
             <a:avLst/>
@@ -38879,6 +38879,42 @@
                 </a:solidFill>
                 <a:latin typeface="Arial"/>
               </a:rPr>
+              <a:t>GPIO 38</a:t>
+            </a:r>
+            <a:r>
+              <a:rPr sz="1500" b="0" i="0">
+                <a:solidFill>
+                  <a:srgbClr val="1A1A1A"/>
+                </a:solidFill>
+                <a:latin typeface="Arial"/>
+              </a:rPr>
+              <a:t> on v1.1 (your board, and the default in </a:t>
+            </a:r>
+            <a:r>
+              <a:rPr sz="1425" b="0" i="0">
+                <a:solidFill>
+                  <a:srgbClr val="1A1A1A"/>
+                </a:solidFill>
+                <a:latin typeface="Courier New"/>
+              </a:rPr>
+              <a:t>config.h</a:t>
+            </a:r>
+            <a:r>
+              <a:rPr sz="1500" b="0" i="0">
+                <a:solidFill>
+                  <a:srgbClr val="1A1A1A"/>
+                </a:solidFill>
+                <a:latin typeface="Arial"/>
+              </a:rPr>
+              <a:t>), </a:t>
+            </a:r>
+            <a:r>
+              <a:rPr sz="1500" b="1" i="0">
+                <a:solidFill>
+                  <a:srgbClr val="1A1A1A"/>
+                </a:solidFill>
+                <a:latin typeface="Arial"/>
+              </a:rPr>
               <a:t>GPIO 48</a:t>
             </a:r>
             <a:r>
@@ -38888,25 +38924,7 @@
                 </a:solidFill>
                 <a:latin typeface="Arial"/>
               </a:rPr>
-              <a:t> on the original board, </a:t>
-            </a:r>
-            <a:r>
-              <a:rPr sz="1500" b="1" i="0">
-                <a:solidFill>
-                  <a:srgbClr val="1A1A1A"/>
-                </a:solidFill>
-                <a:latin typeface="Arial"/>
-              </a:rPr>
-              <a:t>GPIO 38</a:t>
-            </a:r>
-            <a:r>
-              <a:rPr sz="1500" b="0" i="0">
-                <a:solidFill>
-                  <a:srgbClr val="1A1A1A"/>
-                </a:solidFill>
-                <a:latin typeface="Arial"/>
-              </a:rPr>
-              <a:t> on v1.1. Both are in circulation and look identical. The red LED next to the connectors is power.</a:t>
+              <a:t> on the original. Both are in circulation and look identical. The red LED next to the connectors is power.</a:t>
             </a:r>
           </a:p>
           <a:p>

</xml_diff>